<commit_message>
fix: remove fabricated metrics, add tech decision story, write README
- PPT: replace "40% 절감" with "FE 2인" (차세대 커스터머) — no measurement basis
- PPT: remove "50% 절감" from 015 삐삐 앱 outcomes → concrete hybrid benefit statement
- PPT: update 015 삐삐 앱 background with Flutter/Expo/pure RN decision narrative
- PPT/PDF: remove project images from slides (cover crop caused heavy distortion)
- README: document AI usage (site dev, auto-generated PPT/PDF, content QA process)

Co-Authored-By: Claude Sonnet 4.6 <noreply@anthropic.com>
</commit_message>
<xml_diff>
--- a/apps/web/public/portfolio.pptx
+++ b/apps/web/public/portfolio.pptx
@@ -3553,63 +3553,144 @@
           </a:p>
         </p:txBody>
       </p:sp>
-      <p:pic>
-        <p:nvPicPr>
-          <p:cNvPr id="26" name="Image 0" descr="/Users/jinwon/Desktop/jinwon-portfolio/apps/web/public/images/projects/smart-order-1.png">    </p:cNvPr>
-          <p:cNvPicPr>
-            <a:picLocks noChangeAspect="1"/>
-          </p:cNvPicPr>
-          <p:nvPr/>
-        </p:nvPicPr>
-        <p:blipFill>
-          <a:blip r:embed="rId1"/>
-          <a:srcRect l="0" r="0" t="0" b="0"/>
-          <a:stretch/>
-        </p:blipFill>
+      <p:sp>
+        <p:nvSpPr>
+          <p:cNvPr id="26" name="Shape 24"/>
+          <p:cNvSpPr/>
+          <p:nvPr/>
+        </p:nvSpPr>
         <p:spPr>
           <a:xfrm>
             <a:off x="6675120" y="1298448"/>
-            <a:ext cx="5349240" cy="1261872"/>
-          </a:xfrm>
-          <a:prstGeom prst="rect">
-            <a:avLst/>
-          </a:prstGeom>
-        </p:spPr>
-      </p:pic>
-      <p:sp>
-        <p:nvSpPr>
-          <p:cNvPr id="27" name="Shape 24"/>
+            <a:ext cx="5349240" cy="2231136"/>
+          </a:xfrm>
+          <a:prstGeom prst="rect">
+            <a:avLst/>
+          </a:prstGeom>
+          <a:solidFill>
+            <a:srgbClr val="111116"/>
+          </a:solidFill>
+          <a:ln w="12700">
+            <a:solidFill>
+              <a:srgbClr val="111116"/>
+            </a:solidFill>
+            <a:prstDash val="solid"/>
+          </a:ln>
+        </p:spPr>
+      </p:sp>
+      <p:sp>
+        <p:nvSpPr>
+          <p:cNvPr id="27" name="Shape 25"/>
           <p:cNvSpPr/>
           <p:nvPr/>
         </p:nvSpPr>
         <p:spPr>
           <a:xfrm>
             <a:off x="6675120" y="1298448"/>
-            <a:ext cx="5349240" cy="1261872"/>
-          </a:xfrm>
-          <a:prstGeom prst="rect">
-            <a:avLst/>
-          </a:prstGeom>
-          <a:ln w="12700">
-            <a:solidFill>
-              <a:srgbClr val="818CF8">
-                <a:alpha val="50000"/>
-              </a:srgbClr>
-            </a:solidFill>
-            <a:prstDash val="solid"/>
-          </a:ln>
-        </p:spPr>
-      </p:sp>
-      <p:sp>
-        <p:nvSpPr>
-          <p:cNvPr id="28" name="Shape 25"/>
-          <p:cNvSpPr/>
-          <p:nvPr/>
-        </p:nvSpPr>
-        <p:spPr>
-          <a:xfrm>
-            <a:off x="6675120" y="2651760"/>
-            <a:ext cx="5349240" cy="1426464"/>
+            <a:ext cx="64008" cy="2231136"/>
+          </a:xfrm>
+          <a:prstGeom prst="rect">
+            <a:avLst/>
+          </a:prstGeom>
+          <a:solidFill>
+            <a:srgbClr val="818CF8"/>
+          </a:solidFill>
+          <a:ln w="12700">
+            <a:solidFill>
+              <a:srgbClr val="818CF8"/>
+            </a:solidFill>
+            <a:prstDash val="solid"/>
+          </a:ln>
+        </p:spPr>
+      </p:sp>
+      <p:sp>
+        <p:nvSpPr>
+          <p:cNvPr id="28" name="Text 26"/>
+          <p:cNvSpPr/>
+          <p:nvPr/>
+        </p:nvSpPr>
+        <p:spPr>
+          <a:xfrm>
+            <a:off x="6931152" y="1463040"/>
+            <a:ext cx="5001768" cy="1188720"/>
+          </a:xfrm>
+          <a:prstGeom prst="rect">
+            <a:avLst/>
+          </a:prstGeom>
+          <a:noFill/>
+          <a:ln/>
+        </p:spPr>
+        <p:txBody>
+          <a:bodyPr wrap="square" rtlCol="0" anchor="ctr"/>
+          <a:lstStyle/>
+          <a:p>
+            <a:pPr algn="ctr" indent="0" marL="0">
+              <a:buNone/>
+            </a:pPr>
+            <a:r>
+              <a:rPr lang="en-US" sz="4600" b="1" dirty="0">
+                <a:solidFill>
+                  <a:srgbClr val="818CF8"/>
+                </a:solidFill>
+                <a:latin typeface="Malgun Gothic" pitchFamily="34" charset="0"/>
+                <a:ea typeface="Malgun Gothic" pitchFamily="34" charset="-122"/>
+                <a:cs typeface="Malgun Gothic" pitchFamily="34" charset="-120"/>
+              </a:rPr>
+              <a:t>개선</a:t>
+            </a:r>
+            <a:endParaRPr lang="en-US" sz="4600" dirty="0"/>
+          </a:p>
+        </p:txBody>
+      </p:sp>
+      <p:sp>
+        <p:nvSpPr>
+          <p:cNvPr id="29" name="Text 27"/>
+          <p:cNvSpPr/>
+          <p:nvPr/>
+        </p:nvSpPr>
+        <p:spPr>
+          <a:xfrm>
+            <a:off x="6931152" y="2651760"/>
+            <a:ext cx="5001768" cy="329184"/>
+          </a:xfrm>
+          <a:prstGeom prst="rect">
+            <a:avLst/>
+          </a:prstGeom>
+          <a:noFill/>
+          <a:ln/>
+        </p:spPr>
+        <p:txBody>
+          <a:bodyPr wrap="square" rtlCol="0" anchor="ctr"/>
+          <a:lstStyle/>
+          <a:p>
+            <a:pPr algn="ctr" indent="0" marL="0">
+              <a:buNone/>
+            </a:pPr>
+            <a:r>
+              <a:rPr lang="en-US" sz="1100" dirty="0">
+                <a:solidFill>
+                  <a:srgbClr val="8E8E9A"/>
+                </a:solidFill>
+                <a:latin typeface="Malgun Gothic" pitchFamily="34" charset="0"/>
+                <a:ea typeface="Malgun Gothic" pitchFamily="34" charset="-122"/>
+                <a:cs typeface="Malgun Gothic" pitchFamily="34" charset="-120"/>
+              </a:rPr>
+              <a:t>매출 보고 UI 및 사용성 향상</a:t>
+            </a:r>
+            <a:endParaRPr lang="en-US" sz="1100" dirty="0"/>
+          </a:p>
+        </p:txBody>
+      </p:sp>
+      <p:sp>
+        <p:nvSpPr>
+          <p:cNvPr id="30" name="Shape 28"/>
+          <p:cNvSpPr/>
+          <p:nvPr/>
+        </p:nvSpPr>
+        <p:spPr>
+          <a:xfrm>
+            <a:off x="6675120" y="3712464"/>
+            <a:ext cx="5349240" cy="594360"/>
           </a:xfrm>
           <a:prstGeom prst="rect">
             <a:avLst/>
@@ -3627,117 +3708,78 @@
       </p:sp>
       <p:sp>
         <p:nvSpPr>
-          <p:cNvPr id="29" name="Shape 26"/>
-          <p:cNvSpPr/>
-          <p:nvPr/>
-        </p:nvSpPr>
-        <p:spPr>
-          <a:xfrm>
-            <a:off x="6675120" y="2651760"/>
-            <a:ext cx="64008" cy="1426464"/>
-          </a:xfrm>
-          <a:prstGeom prst="rect">
-            <a:avLst/>
-          </a:prstGeom>
-          <a:solidFill>
-            <a:srgbClr val="818CF8"/>
-          </a:solidFill>
-          <a:ln w="12700">
-            <a:solidFill>
-              <a:srgbClr val="818CF8"/>
-            </a:solidFill>
-            <a:prstDash val="solid"/>
-          </a:ln>
-        </p:spPr>
-      </p:sp>
-      <p:sp>
-        <p:nvSpPr>
-          <p:cNvPr id="30" name="Text 27"/>
-          <p:cNvSpPr/>
-          <p:nvPr/>
-        </p:nvSpPr>
-        <p:spPr>
-          <a:xfrm>
-            <a:off x="6931152" y="2743200"/>
-            <a:ext cx="5001768" cy="841248"/>
-          </a:xfrm>
-          <a:prstGeom prst="rect">
-            <a:avLst/>
-          </a:prstGeom>
-          <a:noFill/>
-          <a:ln/>
-        </p:spPr>
-        <p:txBody>
-          <a:bodyPr wrap="square" rtlCol="0" anchor="ctr"/>
-          <a:lstStyle/>
-          <a:p>
-            <a:pPr algn="ctr" indent="0" marL="0">
-              <a:buNone/>
-            </a:pPr>
-            <a:r>
-              <a:rPr lang="en-US" sz="4000" b="1" dirty="0">
-                <a:solidFill>
-                  <a:srgbClr val="818CF8"/>
-                </a:solidFill>
-                <a:latin typeface="Malgun Gothic" pitchFamily="34" charset="0"/>
-                <a:ea typeface="Malgun Gothic" pitchFamily="34" charset="-122"/>
-                <a:cs typeface="Malgun Gothic" pitchFamily="34" charset="-120"/>
-              </a:rPr>
-              <a:t>개선</a:t>
-            </a:r>
-            <a:endParaRPr lang="en-US" sz="4000" dirty="0"/>
-          </a:p>
-        </p:txBody>
-      </p:sp>
-      <p:sp>
-        <p:nvSpPr>
-          <p:cNvPr id="31" name="Text 28"/>
-          <p:cNvSpPr/>
-          <p:nvPr/>
-        </p:nvSpPr>
-        <p:spPr>
-          <a:xfrm>
-            <a:off x="6931152" y="3639312"/>
-            <a:ext cx="5001768" cy="310896"/>
-          </a:xfrm>
-          <a:prstGeom prst="rect">
-            <a:avLst/>
-          </a:prstGeom>
-          <a:noFill/>
-          <a:ln/>
-        </p:spPr>
-        <p:txBody>
-          <a:bodyPr wrap="square" rtlCol="0" anchor="ctr"/>
-          <a:lstStyle/>
-          <a:p>
-            <a:pPr algn="ctr" indent="0" marL="0">
-              <a:buNone/>
-            </a:pPr>
-            <a:r>
-              <a:rPr lang="en-US" sz="1050" dirty="0">
-                <a:solidFill>
-                  <a:srgbClr val="8E8E9A"/>
-                </a:solidFill>
-                <a:latin typeface="Malgun Gothic" pitchFamily="34" charset="0"/>
-                <a:ea typeface="Malgun Gothic" pitchFamily="34" charset="-122"/>
-                <a:cs typeface="Malgun Gothic" pitchFamily="34" charset="-120"/>
-              </a:rPr>
-              <a:t>매출 보고 UI 및 사용성 향상</a:t>
-            </a:r>
-            <a:endParaRPr lang="en-US" sz="1050" dirty="0"/>
-          </a:p>
-        </p:txBody>
-      </p:sp>
-      <p:sp>
-        <p:nvSpPr>
-          <p:cNvPr id="32" name="Shape 29"/>
-          <p:cNvSpPr/>
-          <p:nvPr/>
-        </p:nvSpPr>
-        <p:spPr>
-          <a:xfrm>
-            <a:off x="6675120" y="4187952"/>
-            <a:ext cx="5349240" cy="566928"/>
+          <p:cNvPr id="31" name="Shape 29"/>
+          <p:cNvSpPr/>
+          <p:nvPr/>
+        </p:nvSpPr>
+        <p:spPr>
+          <a:xfrm>
+            <a:off x="6675120" y="3712464"/>
+            <a:ext cx="64008" cy="594360"/>
+          </a:xfrm>
+          <a:prstGeom prst="rect">
+            <a:avLst/>
+          </a:prstGeom>
+          <a:solidFill>
+            <a:srgbClr val="34D399"/>
+          </a:solidFill>
+          <a:ln w="12700">
+            <a:solidFill>
+              <a:srgbClr val="34D399"/>
+            </a:solidFill>
+            <a:prstDash val="solid"/>
+          </a:ln>
+        </p:spPr>
+      </p:sp>
+      <p:sp>
+        <p:nvSpPr>
+          <p:cNvPr id="32" name="Text 30"/>
+          <p:cNvSpPr/>
+          <p:nvPr/>
+        </p:nvSpPr>
+        <p:spPr>
+          <a:xfrm>
+            <a:off x="6931152" y="3776472"/>
+            <a:ext cx="5001768" cy="475488"/>
+          </a:xfrm>
+          <a:prstGeom prst="rect">
+            <a:avLst/>
+          </a:prstGeom>
+          <a:noFill/>
+          <a:ln/>
+        </p:spPr>
+        <p:txBody>
+          <a:bodyPr wrap="square" rtlCol="0" anchor="ctr"/>
+          <a:lstStyle/>
+          <a:p>
+            <a:pPr indent="0" marL="0">
+              <a:buNone/>
+            </a:pPr>
+            <a:r>
+              <a:rPr lang="en-US" sz="1100" dirty="0">
+                <a:solidFill>
+                  <a:srgbClr val="F4F4F6"/>
+                </a:solidFill>
+                <a:latin typeface="Malgun Gothic" pitchFamily="34" charset="0"/>
+                <a:ea typeface="Malgun Gothic" pitchFamily="34" charset="-122"/>
+                <a:cs typeface="Malgun Gothic" pitchFamily="34" charset="-120"/>
+              </a:rPr>
+              <a:t>월별/주별 매출 보고 UI 개선</a:t>
+            </a:r>
+            <a:endParaRPr lang="en-US" sz="1100" dirty="0"/>
+          </a:p>
+        </p:txBody>
+      </p:sp>
+      <p:sp>
+        <p:nvSpPr>
+          <p:cNvPr id="33" name="Shape 31"/>
+          <p:cNvSpPr/>
+          <p:nvPr/>
+        </p:nvSpPr>
+        <p:spPr>
+          <a:xfrm>
+            <a:off x="6675120" y="4425696"/>
+            <a:ext cx="5349240" cy="594360"/>
           </a:xfrm>
           <a:prstGeom prst="rect">
             <a:avLst/>
@@ -3755,14 +3797,14 @@
       </p:sp>
       <p:sp>
         <p:nvSpPr>
-          <p:cNvPr id="33" name="Shape 30"/>
-          <p:cNvSpPr/>
-          <p:nvPr/>
-        </p:nvSpPr>
-        <p:spPr>
-          <a:xfrm>
-            <a:off x="6675120" y="4187952"/>
-            <a:ext cx="64008" cy="566928"/>
+          <p:cNvPr id="34" name="Shape 32"/>
+          <p:cNvSpPr/>
+          <p:nvPr/>
+        </p:nvSpPr>
+        <p:spPr>
+          <a:xfrm>
+            <a:off x="6675120" y="4425696"/>
+            <a:ext cx="64008" cy="594360"/>
           </a:xfrm>
           <a:prstGeom prst="rect">
             <a:avLst/>
@@ -3780,30 +3822,30 @@
       </p:sp>
       <p:sp>
         <p:nvSpPr>
-          <p:cNvPr id="34" name="Text 31"/>
-          <p:cNvSpPr/>
-          <p:nvPr/>
-        </p:nvSpPr>
-        <p:spPr>
-          <a:xfrm>
-            <a:off x="6931152" y="4242816"/>
-            <a:ext cx="5001768" cy="457200"/>
-          </a:xfrm>
-          <a:prstGeom prst="rect">
-            <a:avLst/>
-          </a:prstGeom>
-          <a:noFill/>
-          <a:ln/>
-        </p:spPr>
-        <p:txBody>
-          <a:bodyPr wrap="square" rtlCol="0" anchor="ctr"/>
-          <a:lstStyle/>
-          <a:p>
-            <a:pPr indent="0" marL="0">
-              <a:buNone/>
-            </a:pPr>
-            <a:r>
-              <a:rPr lang="en-US" sz="1050" dirty="0">
+          <p:cNvPr id="35" name="Text 33"/>
+          <p:cNvSpPr/>
+          <p:nvPr/>
+        </p:nvSpPr>
+        <p:spPr>
+          <a:xfrm>
+            <a:off x="6931152" y="4489704"/>
+            <a:ext cx="5001768" cy="475488"/>
+          </a:xfrm>
+          <a:prstGeom prst="rect">
+            <a:avLst/>
+          </a:prstGeom>
+          <a:noFill/>
+          <a:ln/>
+        </p:spPr>
+        <p:txBody>
+          <a:bodyPr wrap="square" rtlCol="0" anchor="ctr"/>
+          <a:lstStyle/>
+          <a:p>
+            <a:pPr indent="0" marL="0">
+              <a:buNone/>
+            </a:pPr>
+            <a:r>
+              <a:rPr lang="en-US" sz="1100" dirty="0">
                 <a:solidFill>
                   <a:srgbClr val="F4F4F6"/>
                 </a:solidFill>
@@ -3811,104 +3853,15 @@
                 <a:ea typeface="Malgun Gothic" pitchFamily="34" charset="-122"/>
                 <a:cs typeface="Malgun Gothic" pitchFamily="34" charset="-120"/>
               </a:rPr>
-              <a:t>월별/주별 매출 보고 UI 개선</a:t>
-            </a:r>
-            <a:endParaRPr lang="en-US" sz="1050" dirty="0"/>
-          </a:p>
-        </p:txBody>
-      </p:sp>
-      <p:sp>
-        <p:nvSpPr>
-          <p:cNvPr id="35" name="Shape 32"/>
-          <p:cNvSpPr/>
-          <p:nvPr/>
-        </p:nvSpPr>
-        <p:spPr>
-          <a:xfrm>
-            <a:off x="6675120" y="4864608"/>
-            <a:ext cx="5349240" cy="566928"/>
-          </a:xfrm>
-          <a:prstGeom prst="rect">
-            <a:avLst/>
-          </a:prstGeom>
-          <a:solidFill>
-            <a:srgbClr val="111116"/>
-          </a:solidFill>
-          <a:ln w="12700">
-            <a:solidFill>
-              <a:srgbClr val="111116"/>
-            </a:solidFill>
-            <a:prstDash val="solid"/>
-          </a:ln>
-        </p:spPr>
-      </p:sp>
-      <p:sp>
-        <p:nvSpPr>
-          <p:cNvPr id="36" name="Shape 33"/>
-          <p:cNvSpPr/>
-          <p:nvPr/>
-        </p:nvSpPr>
-        <p:spPr>
-          <a:xfrm>
-            <a:off x="6675120" y="4864608"/>
-            <a:ext cx="64008" cy="566928"/>
-          </a:xfrm>
-          <a:prstGeom prst="rect">
-            <a:avLst/>
-          </a:prstGeom>
-          <a:solidFill>
-            <a:srgbClr val="34D399"/>
-          </a:solidFill>
-          <a:ln w="12700">
-            <a:solidFill>
-              <a:srgbClr val="34D399"/>
-            </a:solidFill>
-            <a:prstDash val="solid"/>
-          </a:ln>
-        </p:spPr>
-      </p:sp>
-      <p:sp>
-        <p:nvSpPr>
-          <p:cNvPr id="37" name="Text 34"/>
-          <p:cNvSpPr/>
-          <p:nvPr/>
-        </p:nvSpPr>
-        <p:spPr>
-          <a:xfrm>
-            <a:off x="6931152" y="4919472"/>
-            <a:ext cx="5001768" cy="457200"/>
-          </a:xfrm>
-          <a:prstGeom prst="rect">
-            <a:avLst/>
-          </a:prstGeom>
-          <a:noFill/>
-          <a:ln/>
-        </p:spPr>
-        <p:txBody>
-          <a:bodyPr wrap="square" rtlCol="0" anchor="ctr"/>
-          <a:lstStyle/>
-          <a:p>
-            <a:pPr indent="0" marL="0">
-              <a:buNone/>
-            </a:pPr>
-            <a:r>
-              <a:rPr lang="en-US" sz="1050" dirty="0">
-                <a:solidFill>
-                  <a:srgbClr val="F4F4F6"/>
-                </a:solidFill>
-                <a:latin typeface="Malgun Gothic" pitchFamily="34" charset="0"/>
-                <a:ea typeface="Malgun Gothic" pitchFamily="34" charset="-122"/>
-                <a:cs typeface="Malgun Gothic" pitchFamily="34" charset="-120"/>
-              </a:rPr>
               <a:t>주문 및 결제 기반 서비스 운영 환경 경험</a:t>
             </a:r>
-            <a:endParaRPr lang="en-US" sz="1050" dirty="0"/>
-          </a:p>
-        </p:txBody>
-      </p:sp>
-      <p:sp>
-        <p:nvSpPr>
-          <p:cNvPr id="38" name="Shape 35"/>
+            <a:endParaRPr lang="en-US" sz="1100" dirty="0"/>
+          </a:p>
+        </p:txBody>
+      </p:sp>
+      <p:sp>
+        <p:nvSpPr>
+          <p:cNvPr id="36" name="Shape 34"/>
           <p:cNvSpPr/>
           <p:nvPr/>
         </p:nvSpPr>
@@ -3933,7 +3886,7 @@
       </p:sp>
       <p:sp>
         <p:nvSpPr>
-          <p:cNvPr id="39" name="Text 36"/>
+          <p:cNvPr id="37" name="Text 35"/>
           <p:cNvSpPr/>
           <p:nvPr/>
         </p:nvSpPr>
@@ -6765,7 +6718,7 @@
                 <a:ea typeface="Malgun Gothic" pitchFamily="34" charset="-122"/>
                 <a:cs typeface="Malgun Gothic" pitchFamily="34" charset="-120"/>
               </a:rPr>
-              <a:t>40%</a:t>
+              <a:t>FE 2인</a:t>
             </a:r>
             <a:endParaRPr lang="en-US" sz="6400" dirty="0"/>
           </a:p>
@@ -6827,7 +6780,7 @@
                 <a:ea typeface="Malgun Gothic" pitchFamily="34" charset="-122"/>
                 <a:cs typeface="Malgun Gothic" pitchFamily="34" charset="-120"/>
               </a:rPr>
-              <a:t>유지보수 공수 절감</a:t>
+              <a:t>설계→배포 전 과정 주도</a:t>
             </a:r>
             <a:endParaRPr lang="en-US" sz="1300" dirty="0"/>
           </a:p>
@@ -6866,7 +6819,7 @@
                 <a:ea typeface="Malgun Gothic" pitchFamily="34" charset="-122"/>
                 <a:cs typeface="Malgun Gothic" pitchFamily="34" charset="-120"/>
               </a:rPr>
-              <a:t>015 웹 React Query + 컨벤션</a:t>
+              <a:t>차세대 커스터머 0→1 신규 구축</a:t>
             </a:r>
             <a:endParaRPr lang="en-US" sz="950" dirty="0"/>
           </a:p>
@@ -8588,7 +8541,7 @@
                 <a:ea typeface="Malgun Gothic" pitchFamily="34" charset="-122"/>
                 <a:cs typeface="Malgun Gothic" pitchFamily="34" charset="-120"/>
               </a:rPr>
-              <a:t>기존 서비스 없이 처음부터 설계·구축. React Native 기반 하이브리드 메시징 앱을 앱스토어·플레이스토어 동시 출시 목표로 개발.</a:t>
+              <a:t>Flutter · Expo · 순수 RN 세 가지 검토. Expo는 FCM·인앱결제에서 ejection이 불가피했고, Flutter는 Dart 언어 학습 비용 이슈. 기존 React 경험을 활용하면서 Native 완전 제어권을 확보할 수 있는 순수 RN 0.81 선택.</a:t>
             </a:r>
             <a:endParaRPr lang="en-US" sz="1150" dirty="0"/>
           </a:p>
@@ -8714,7 +8667,7 @@
                 <a:ea typeface="Malgun Gothic" pitchFamily="34" charset="-122"/>
                 <a:cs typeface="Malgun Gothic" pitchFamily="34" charset="-120"/>
               </a:rPr>
-              <a:t>•  앱 전반 아키텍처 설계 및 기술 스택 선정 — Expo 배제, 순수 RN 0.81 채택 (Native 모듈 확장성 확보)</a:t>
+              <a:t>•  앱 전반 아키텍처 설계 및 기술 스택 선정 — 순수 RN 0.81 채택 (Expo ejection 리스크 회피, JS 생태계 유지 + Native 완전 제어)</a:t>
             </a:r>
             <a:endParaRPr lang="en-US" sz="1150" dirty="0"/>
           </a:p>
@@ -8837,63 +8790,144 @@
           </a:p>
         </p:txBody>
       </p:sp>
-      <p:pic>
-        <p:nvPicPr>
-          <p:cNvPr id="21" name="Image 0" descr="/Users/jinwon/Desktop/jinwon-portfolio/apps/web/public/images/projects/bbi-1.png">    </p:cNvPr>
-          <p:cNvPicPr>
-            <a:picLocks noChangeAspect="1"/>
-          </p:cNvPicPr>
-          <p:nvPr/>
-        </p:nvPicPr>
-        <p:blipFill>
-          <a:blip r:embed="rId1"/>
-          <a:srcRect l="0" r="0" t="0" b="0"/>
-          <a:stretch/>
-        </p:blipFill>
+      <p:sp>
+        <p:nvSpPr>
+          <p:cNvPr id="21" name="Shape 19"/>
+          <p:cNvSpPr/>
+          <p:nvPr/>
+        </p:nvSpPr>
         <p:spPr>
           <a:xfrm>
             <a:off x="6675120" y="1298448"/>
-            <a:ext cx="5349240" cy="1261872"/>
-          </a:xfrm>
-          <a:prstGeom prst="rect">
-            <a:avLst/>
-          </a:prstGeom>
-        </p:spPr>
-      </p:pic>
-      <p:sp>
-        <p:nvSpPr>
-          <p:cNvPr id="22" name="Shape 19"/>
+            <a:ext cx="5349240" cy="2231136"/>
+          </a:xfrm>
+          <a:prstGeom prst="rect">
+            <a:avLst/>
+          </a:prstGeom>
+          <a:solidFill>
+            <a:srgbClr val="111116"/>
+          </a:solidFill>
+          <a:ln w="12700">
+            <a:solidFill>
+              <a:srgbClr val="111116"/>
+            </a:solidFill>
+            <a:prstDash val="solid"/>
+          </a:ln>
+        </p:spPr>
+      </p:sp>
+      <p:sp>
+        <p:nvSpPr>
+          <p:cNvPr id="22" name="Shape 20"/>
           <p:cNvSpPr/>
           <p:nvPr/>
         </p:nvSpPr>
         <p:spPr>
           <a:xfrm>
             <a:off x="6675120" y="1298448"/>
-            <a:ext cx="5349240" cy="1261872"/>
-          </a:xfrm>
-          <a:prstGeom prst="rect">
-            <a:avLst/>
-          </a:prstGeom>
-          <a:ln w="12700">
-            <a:solidFill>
-              <a:srgbClr val="818CF8">
-                <a:alpha val="50000"/>
-              </a:srgbClr>
-            </a:solidFill>
-            <a:prstDash val="solid"/>
-          </a:ln>
-        </p:spPr>
-      </p:sp>
-      <p:sp>
-        <p:nvSpPr>
-          <p:cNvPr id="23" name="Shape 20"/>
-          <p:cNvSpPr/>
-          <p:nvPr/>
-        </p:nvSpPr>
-        <p:spPr>
-          <a:xfrm>
-            <a:off x="6675120" y="2651760"/>
-            <a:ext cx="5349240" cy="1426464"/>
+            <a:ext cx="64008" cy="2231136"/>
+          </a:xfrm>
+          <a:prstGeom prst="rect">
+            <a:avLst/>
+          </a:prstGeom>
+          <a:solidFill>
+            <a:srgbClr val="818CF8"/>
+          </a:solidFill>
+          <a:ln w="12700">
+            <a:solidFill>
+              <a:srgbClr val="818CF8"/>
+            </a:solidFill>
+            <a:prstDash val="solid"/>
+          </a:ln>
+        </p:spPr>
+      </p:sp>
+      <p:sp>
+        <p:nvSpPr>
+          <p:cNvPr id="23" name="Text 21"/>
+          <p:cNvSpPr/>
+          <p:nvPr/>
+        </p:nvSpPr>
+        <p:spPr>
+          <a:xfrm>
+            <a:off x="6931152" y="1463040"/>
+            <a:ext cx="5001768" cy="1188720"/>
+          </a:xfrm>
+          <a:prstGeom prst="rect">
+            <a:avLst/>
+          </a:prstGeom>
+          <a:noFill/>
+          <a:ln/>
+        </p:spPr>
+        <p:txBody>
+          <a:bodyPr wrap="square" rtlCol="0" anchor="ctr"/>
+          <a:lstStyle/>
+          <a:p>
+            <a:pPr algn="ctr" indent="0" marL="0">
+              <a:buNone/>
+            </a:pPr>
+            <a:r>
+              <a:rPr lang="en-US" sz="4600" b="1" dirty="0">
+                <a:solidFill>
+                  <a:srgbClr val="818CF8"/>
+                </a:solidFill>
+                <a:latin typeface="Malgun Gothic" pitchFamily="34" charset="0"/>
+                <a:ea typeface="Malgun Gothic" pitchFamily="34" charset="-122"/>
+                <a:cs typeface="Malgun Gothic" pitchFamily="34" charset="-120"/>
+              </a:rPr>
+              <a:t>정식 출시</a:t>
+            </a:r>
+            <a:endParaRPr lang="en-US" sz="4600" dirty="0"/>
+          </a:p>
+        </p:txBody>
+      </p:sp>
+      <p:sp>
+        <p:nvSpPr>
+          <p:cNvPr id="24" name="Text 22"/>
+          <p:cNvSpPr/>
+          <p:nvPr/>
+        </p:nvSpPr>
+        <p:spPr>
+          <a:xfrm>
+            <a:off x="6931152" y="2651760"/>
+            <a:ext cx="5001768" cy="329184"/>
+          </a:xfrm>
+          <a:prstGeom prst="rect">
+            <a:avLst/>
+          </a:prstGeom>
+          <a:noFill/>
+          <a:ln/>
+        </p:spPr>
+        <p:txBody>
+          <a:bodyPr wrap="square" rtlCol="0" anchor="ctr"/>
+          <a:lstStyle/>
+          <a:p>
+            <a:pPr algn="ctr" indent="0" marL="0">
+              <a:buNone/>
+            </a:pPr>
+            <a:r>
+              <a:rPr lang="en-US" sz="1100" dirty="0">
+                <a:solidFill>
+                  <a:srgbClr val="8E8E9A"/>
+                </a:solidFill>
+                <a:latin typeface="Malgun Gothic" pitchFamily="34" charset="0"/>
+                <a:ea typeface="Malgun Gothic" pitchFamily="34" charset="-122"/>
+                <a:cs typeface="Malgun Gothic" pitchFamily="34" charset="-120"/>
+              </a:rPr>
+              <a:t>앱스토어 · 플레이스토어 동시 론칭</a:t>
+            </a:r>
+            <a:endParaRPr lang="en-US" sz="1100" dirty="0"/>
+          </a:p>
+        </p:txBody>
+      </p:sp>
+      <p:sp>
+        <p:nvSpPr>
+          <p:cNvPr id="25" name="Shape 23"/>
+          <p:cNvSpPr/>
+          <p:nvPr/>
+        </p:nvSpPr>
+        <p:spPr>
+          <a:xfrm>
+            <a:off x="6675120" y="3712464"/>
+            <a:ext cx="5349240" cy="594360"/>
           </a:xfrm>
           <a:prstGeom prst="rect">
             <a:avLst/>
@@ -8911,117 +8945,78 @@
       </p:sp>
       <p:sp>
         <p:nvSpPr>
-          <p:cNvPr id="24" name="Shape 21"/>
-          <p:cNvSpPr/>
-          <p:nvPr/>
-        </p:nvSpPr>
-        <p:spPr>
-          <a:xfrm>
-            <a:off x="6675120" y="2651760"/>
-            <a:ext cx="64008" cy="1426464"/>
-          </a:xfrm>
-          <a:prstGeom prst="rect">
-            <a:avLst/>
-          </a:prstGeom>
-          <a:solidFill>
-            <a:srgbClr val="818CF8"/>
-          </a:solidFill>
-          <a:ln w="12700">
-            <a:solidFill>
-              <a:srgbClr val="818CF8"/>
-            </a:solidFill>
-            <a:prstDash val="solid"/>
-          </a:ln>
-        </p:spPr>
-      </p:sp>
-      <p:sp>
-        <p:nvSpPr>
-          <p:cNvPr id="25" name="Text 22"/>
-          <p:cNvSpPr/>
-          <p:nvPr/>
-        </p:nvSpPr>
-        <p:spPr>
-          <a:xfrm>
-            <a:off x="6931152" y="2743200"/>
-            <a:ext cx="5001768" cy="841248"/>
-          </a:xfrm>
-          <a:prstGeom prst="rect">
-            <a:avLst/>
-          </a:prstGeom>
-          <a:noFill/>
-          <a:ln/>
-        </p:spPr>
-        <p:txBody>
-          <a:bodyPr wrap="square" rtlCol="0" anchor="ctr"/>
-          <a:lstStyle/>
-          <a:p>
-            <a:pPr algn="ctr" indent="0" marL="0">
-              <a:buNone/>
-            </a:pPr>
-            <a:r>
-              <a:rPr lang="en-US" sz="4000" b="1" dirty="0">
-                <a:solidFill>
-                  <a:srgbClr val="818CF8"/>
-                </a:solidFill>
-                <a:latin typeface="Malgun Gothic" pitchFamily="34" charset="0"/>
-                <a:ea typeface="Malgun Gothic" pitchFamily="34" charset="-122"/>
-                <a:cs typeface="Malgun Gothic" pitchFamily="34" charset="-120"/>
-              </a:rPr>
-              <a:t>정식 출시</a:t>
-            </a:r>
-            <a:endParaRPr lang="en-US" sz="4000" dirty="0"/>
-          </a:p>
-        </p:txBody>
-      </p:sp>
-      <p:sp>
-        <p:nvSpPr>
-          <p:cNvPr id="26" name="Text 23"/>
-          <p:cNvSpPr/>
-          <p:nvPr/>
-        </p:nvSpPr>
-        <p:spPr>
-          <a:xfrm>
-            <a:off x="6931152" y="3639312"/>
-            <a:ext cx="5001768" cy="310896"/>
-          </a:xfrm>
-          <a:prstGeom prst="rect">
-            <a:avLst/>
-          </a:prstGeom>
-          <a:noFill/>
-          <a:ln/>
-        </p:spPr>
-        <p:txBody>
-          <a:bodyPr wrap="square" rtlCol="0" anchor="ctr"/>
-          <a:lstStyle/>
-          <a:p>
-            <a:pPr algn="ctr" indent="0" marL="0">
-              <a:buNone/>
-            </a:pPr>
-            <a:r>
-              <a:rPr lang="en-US" sz="1050" dirty="0">
-                <a:solidFill>
-                  <a:srgbClr val="8E8E9A"/>
-                </a:solidFill>
-                <a:latin typeface="Malgun Gothic" pitchFamily="34" charset="0"/>
-                <a:ea typeface="Malgun Gothic" pitchFamily="34" charset="-122"/>
-                <a:cs typeface="Malgun Gothic" pitchFamily="34" charset="-120"/>
-              </a:rPr>
-              <a:t>앱스토어 · 플레이스토어 동시 론칭</a:t>
-            </a:r>
-            <a:endParaRPr lang="en-US" sz="1050" dirty="0"/>
-          </a:p>
-        </p:txBody>
-      </p:sp>
-      <p:sp>
-        <p:nvSpPr>
-          <p:cNvPr id="27" name="Shape 24"/>
-          <p:cNvSpPr/>
-          <p:nvPr/>
-        </p:nvSpPr>
-        <p:spPr>
-          <a:xfrm>
-            <a:off x="6675120" y="4187952"/>
-            <a:ext cx="5349240" cy="566928"/>
+          <p:cNvPr id="26" name="Shape 24"/>
+          <p:cNvSpPr/>
+          <p:nvPr/>
+        </p:nvSpPr>
+        <p:spPr>
+          <a:xfrm>
+            <a:off x="6675120" y="3712464"/>
+            <a:ext cx="64008" cy="594360"/>
+          </a:xfrm>
+          <a:prstGeom prst="rect">
+            <a:avLst/>
+          </a:prstGeom>
+          <a:solidFill>
+            <a:srgbClr val="34D399"/>
+          </a:solidFill>
+          <a:ln w="12700">
+            <a:solidFill>
+              <a:srgbClr val="34D399"/>
+            </a:solidFill>
+            <a:prstDash val="solid"/>
+          </a:ln>
+        </p:spPr>
+      </p:sp>
+      <p:sp>
+        <p:nvSpPr>
+          <p:cNvPr id="27" name="Text 25"/>
+          <p:cNvSpPr/>
+          <p:nvPr/>
+        </p:nvSpPr>
+        <p:spPr>
+          <a:xfrm>
+            <a:off x="6931152" y="3776472"/>
+            <a:ext cx="5001768" cy="475488"/>
+          </a:xfrm>
+          <a:prstGeom prst="rect">
+            <a:avLst/>
+          </a:prstGeom>
+          <a:noFill/>
+          <a:ln/>
+        </p:spPr>
+        <p:txBody>
+          <a:bodyPr wrap="square" rtlCol="0" anchor="ctr"/>
+          <a:lstStyle/>
+          <a:p>
+            <a:pPr indent="0" marL="0">
+              <a:buNone/>
+            </a:pPr>
+            <a:r>
+              <a:rPr lang="en-US" sz="1100" dirty="0">
+                <a:solidFill>
+                  <a:srgbClr val="F4F4F6"/>
+                </a:solidFill>
+                <a:latin typeface="Malgun Gothic" pitchFamily="34" charset="0"/>
+                <a:ea typeface="Malgun Gothic" pitchFamily="34" charset="-122"/>
+                <a:cs typeface="Malgun Gothic" pitchFamily="34" charset="-120"/>
+              </a:rPr>
+              <a:t>하이브리드 구조로 콘텐츠 업데이트 시 앱 재배포 없이 즉시 반영</a:t>
+            </a:r>
+            <a:endParaRPr lang="en-US" sz="1100" dirty="0"/>
+          </a:p>
+        </p:txBody>
+      </p:sp>
+      <p:sp>
+        <p:nvSpPr>
+          <p:cNvPr id="28" name="Shape 26"/>
+          <p:cNvSpPr/>
+          <p:nvPr/>
+        </p:nvSpPr>
+        <p:spPr>
+          <a:xfrm>
+            <a:off x="6675120" y="4425696"/>
+            <a:ext cx="5349240" cy="594360"/>
           </a:xfrm>
           <a:prstGeom prst="rect">
             <a:avLst/>
@@ -9039,14 +9034,14 @@
       </p:sp>
       <p:sp>
         <p:nvSpPr>
-          <p:cNvPr id="28" name="Shape 25"/>
-          <p:cNvSpPr/>
-          <p:nvPr/>
-        </p:nvSpPr>
-        <p:spPr>
-          <a:xfrm>
-            <a:off x="6675120" y="4187952"/>
-            <a:ext cx="64008" cy="566928"/>
+          <p:cNvPr id="29" name="Shape 27"/>
+          <p:cNvSpPr/>
+          <p:nvPr/>
+        </p:nvSpPr>
+        <p:spPr>
+          <a:xfrm>
+            <a:off x="6675120" y="4425696"/>
+            <a:ext cx="64008" cy="594360"/>
           </a:xfrm>
           <a:prstGeom prst="rect">
             <a:avLst/>
@@ -9064,30 +9059,30 @@
       </p:sp>
       <p:sp>
         <p:nvSpPr>
-          <p:cNvPr id="29" name="Text 26"/>
-          <p:cNvSpPr/>
-          <p:nvPr/>
-        </p:nvSpPr>
-        <p:spPr>
-          <a:xfrm>
-            <a:off x="6931152" y="4242816"/>
-            <a:ext cx="5001768" cy="457200"/>
-          </a:xfrm>
-          <a:prstGeom prst="rect">
-            <a:avLst/>
-          </a:prstGeom>
-          <a:noFill/>
-          <a:ln/>
-        </p:spPr>
-        <p:txBody>
-          <a:bodyPr wrap="square" rtlCol="0" anchor="ctr"/>
-          <a:lstStyle/>
-          <a:p>
-            <a:pPr indent="0" marL="0">
-              <a:buNone/>
-            </a:pPr>
-            <a:r>
-              <a:rPr lang="en-US" sz="1050" dirty="0">
+          <p:cNvPr id="30" name="Text 28"/>
+          <p:cNvSpPr/>
+          <p:nvPr/>
+        </p:nvSpPr>
+        <p:spPr>
+          <a:xfrm>
+            <a:off x="6931152" y="4489704"/>
+            <a:ext cx="5001768" cy="475488"/>
+          </a:xfrm>
+          <a:prstGeom prst="rect">
+            <a:avLst/>
+          </a:prstGeom>
+          <a:noFill/>
+          <a:ln/>
+        </p:spPr>
+        <p:txBody>
+          <a:bodyPr wrap="square" rtlCol="0" anchor="ctr"/>
+          <a:lstStyle/>
+          <a:p>
+            <a:pPr indent="0" marL="0">
+              <a:buNone/>
+            </a:pPr>
+            <a:r>
+              <a:rPr lang="en-US" sz="1100" dirty="0">
                 <a:solidFill>
                   <a:srgbClr val="F4F4F6"/>
                 </a:solidFill>
@@ -9095,104 +9090,15 @@
                 <a:ea typeface="Malgun Gothic" pitchFamily="34" charset="-122"/>
                 <a:cs typeface="Malgun Gothic" pitchFamily="34" charset="-120"/>
               </a:rPr>
-              <a:t>개발·운영 공수 50% 절감 (하이브리드 구조)</a:t>
-            </a:r>
-            <a:endParaRPr lang="en-US" sz="1050" dirty="0"/>
-          </a:p>
-        </p:txBody>
-      </p:sp>
-      <p:sp>
-        <p:nvSpPr>
-          <p:cNvPr id="30" name="Shape 27"/>
-          <p:cNvSpPr/>
-          <p:nvPr/>
-        </p:nvSpPr>
-        <p:spPr>
-          <a:xfrm>
-            <a:off x="6675120" y="4864608"/>
-            <a:ext cx="5349240" cy="566928"/>
-          </a:xfrm>
-          <a:prstGeom prst="rect">
-            <a:avLst/>
-          </a:prstGeom>
-          <a:solidFill>
-            <a:srgbClr val="111116"/>
-          </a:solidFill>
-          <a:ln w="12700">
-            <a:solidFill>
-              <a:srgbClr val="111116"/>
-            </a:solidFill>
-            <a:prstDash val="solid"/>
-          </a:ln>
-        </p:spPr>
-      </p:sp>
-      <p:sp>
-        <p:nvSpPr>
-          <p:cNvPr id="31" name="Shape 28"/>
-          <p:cNvSpPr/>
-          <p:nvPr/>
-        </p:nvSpPr>
-        <p:spPr>
-          <a:xfrm>
-            <a:off x="6675120" y="4864608"/>
-            <a:ext cx="64008" cy="566928"/>
-          </a:xfrm>
-          <a:prstGeom prst="rect">
-            <a:avLst/>
-          </a:prstGeom>
-          <a:solidFill>
-            <a:srgbClr val="34D399"/>
-          </a:solidFill>
-          <a:ln w="12700">
-            <a:solidFill>
-              <a:srgbClr val="34D399"/>
-            </a:solidFill>
-            <a:prstDash val="solid"/>
-          </a:ln>
-        </p:spPr>
-      </p:sp>
-      <p:sp>
-        <p:nvSpPr>
-          <p:cNvPr id="32" name="Text 29"/>
-          <p:cNvSpPr/>
-          <p:nvPr/>
-        </p:nvSpPr>
-        <p:spPr>
-          <a:xfrm>
-            <a:off x="6931152" y="4919472"/>
-            <a:ext cx="5001768" cy="457200"/>
-          </a:xfrm>
-          <a:prstGeom prst="rect">
-            <a:avLst/>
-          </a:prstGeom>
-          <a:noFill/>
-          <a:ln/>
-        </p:spPr>
-        <p:txBody>
-          <a:bodyPr wrap="square" rtlCol="0" anchor="ctr"/>
-          <a:lstStyle/>
-          <a:p>
-            <a:pPr indent="0" marL="0">
-              <a:buNone/>
-            </a:pPr>
-            <a:r>
-              <a:rPr lang="en-US" sz="1050" dirty="0">
-                <a:solidFill>
-                  <a:srgbClr val="F4F4F6"/>
-                </a:solidFill>
-                <a:latin typeface="Malgun Gothic" pitchFamily="34" charset="0"/>
-                <a:ea typeface="Malgun Gothic" pitchFamily="34" charset="-122"/>
-                <a:cs typeface="Malgun Gothic" pitchFamily="34" charset="-120"/>
-              </a:rPr>
-              <a:t>콜드스타트·푸시 응답속도 개선</a:t>
-            </a:r>
-            <a:endParaRPr lang="en-US" sz="1050" dirty="0"/>
-          </a:p>
-        </p:txBody>
-      </p:sp>
-      <p:sp>
-        <p:nvSpPr>
-          <p:cNvPr id="33" name="Shape 30"/>
+              <a:t>앱스토어·플레이스토어 동시 정식 출시 달성</a:t>
+            </a:r>
+            <a:endParaRPr lang="en-US" sz="1100" dirty="0"/>
+          </a:p>
+        </p:txBody>
+      </p:sp>
+      <p:sp>
+        <p:nvSpPr>
+          <p:cNvPr id="31" name="Shape 29"/>
           <p:cNvSpPr/>
           <p:nvPr/>
         </p:nvSpPr>
@@ -9217,7 +9123,7 @@
       </p:sp>
       <p:sp>
         <p:nvSpPr>
-          <p:cNvPr id="34" name="Text 31"/>
+          <p:cNvPr id="32" name="Text 30"/>
           <p:cNvSpPr/>
           <p:nvPr/>
         </p:nvSpPr>
@@ -10092,63 +9998,161 @@
           </a:p>
         </p:txBody>
       </p:sp>
-      <p:pic>
-        <p:nvPicPr>
-          <p:cNvPr id="26" name="Image 0" descr="/Users/jinwon/Desktop/jinwon-portfolio/apps/web/public/images/projects/web015-3.png">    </p:cNvPr>
-          <p:cNvPicPr>
-            <a:picLocks noChangeAspect="1"/>
-          </p:cNvPicPr>
-          <p:nvPr/>
-        </p:nvPicPr>
-        <p:blipFill>
-          <a:blip r:embed="rId1"/>
-          <a:srcRect l="0" r="0" t="0" b="0"/>
-          <a:stretch/>
-        </p:blipFill>
+      <p:sp>
+        <p:nvSpPr>
+          <p:cNvPr id="26" name="Shape 24"/>
+          <p:cNvSpPr/>
+          <p:nvPr/>
+        </p:nvSpPr>
         <p:spPr>
           <a:xfrm>
             <a:off x="6675120" y="1298448"/>
-            <a:ext cx="5349240" cy="1261872"/>
-          </a:xfrm>
-          <a:prstGeom prst="rect">
-            <a:avLst/>
-          </a:prstGeom>
-        </p:spPr>
-      </p:pic>
-      <p:sp>
-        <p:nvSpPr>
-          <p:cNvPr id="27" name="Shape 24"/>
+            <a:ext cx="5349240" cy="2231136"/>
+          </a:xfrm>
+          <a:prstGeom prst="rect">
+            <a:avLst/>
+          </a:prstGeom>
+          <a:solidFill>
+            <a:srgbClr val="111116"/>
+          </a:solidFill>
+          <a:ln w="12700">
+            <a:solidFill>
+              <a:srgbClr val="111116"/>
+            </a:solidFill>
+            <a:prstDash val="solid"/>
+          </a:ln>
+        </p:spPr>
+      </p:sp>
+      <p:sp>
+        <p:nvSpPr>
+          <p:cNvPr id="27" name="Shape 25"/>
           <p:cNvSpPr/>
           <p:nvPr/>
         </p:nvSpPr>
         <p:spPr>
           <a:xfrm>
             <a:off x="6675120" y="1298448"/>
-            <a:ext cx="5349240" cy="1261872"/>
-          </a:xfrm>
-          <a:prstGeom prst="rect">
-            <a:avLst/>
-          </a:prstGeom>
-          <a:ln w="12700">
-            <a:solidFill>
-              <a:srgbClr val="818CF8">
-                <a:alpha val="50000"/>
-              </a:srgbClr>
-            </a:solidFill>
-            <a:prstDash val="solid"/>
-          </a:ln>
-        </p:spPr>
-      </p:sp>
-      <p:sp>
-        <p:nvSpPr>
-          <p:cNvPr id="28" name="Shape 25"/>
-          <p:cNvSpPr/>
-          <p:nvPr/>
-        </p:nvSpPr>
-        <p:spPr>
-          <a:xfrm>
-            <a:off x="6675120" y="2651760"/>
-            <a:ext cx="5349240" cy="1426464"/>
+            <a:ext cx="64008" cy="2231136"/>
+          </a:xfrm>
+          <a:prstGeom prst="rect">
+            <a:avLst/>
+          </a:prstGeom>
+          <a:solidFill>
+            <a:srgbClr val="818CF8"/>
+          </a:solidFill>
+          <a:ln w="12700">
+            <a:solidFill>
+              <a:srgbClr val="818CF8"/>
+            </a:solidFill>
+            <a:prstDash val="solid"/>
+          </a:ln>
+        </p:spPr>
+      </p:sp>
+      <p:sp>
+        <p:nvSpPr>
+          <p:cNvPr id="28" name="Text 26"/>
+          <p:cNvSpPr/>
+          <p:nvPr/>
+        </p:nvSpPr>
+        <p:spPr>
+          <a:xfrm>
+            <a:off x="6931152" y="1463040"/>
+            <a:ext cx="5001768" cy="1188720"/>
+          </a:xfrm>
+          <a:prstGeom prst="rect">
+            <a:avLst/>
+          </a:prstGeom>
+          <a:noFill/>
+          <a:ln/>
+        </p:spPr>
+        <p:txBody>
+          <a:bodyPr wrap="square" rtlCol="0" anchor="ctr"/>
+          <a:lstStyle/>
+          <a:p>
+            <a:pPr algn="ctr" indent="0" marL="0">
+              <a:buNone/>
+            </a:pPr>
+            <a:r>
+              <a:rPr lang="en-US" sz="4600" b="1" dirty="0">
+                <a:solidFill>
+                  <a:srgbClr val="818CF8"/>
+                </a:solidFill>
+                <a:latin typeface="Malgun Gothic" pitchFamily="34" charset="0"/>
+                <a:ea typeface="Malgun Gothic" pitchFamily="34" charset="-122"/>
+                <a:cs typeface="Malgun Gothic" pitchFamily="34" charset="-120"/>
+              </a:rPr>
+              <a:t>exports</a:t>
+            </a:r>
+            <a:endParaRPr lang="en-US" sz="4600" dirty="0"/>
+          </a:p>
+          <a:p>
+            <a:pPr algn="ctr" indent="0" marL="0">
+              <a:buNone/>
+            </a:pPr>
+            <a:r>
+              <a:rPr lang="en-US" sz="4600" b="1" dirty="0">
+                <a:solidFill>
+                  <a:srgbClr val="818CF8"/>
+                </a:solidFill>
+                <a:latin typeface="Malgun Gothic" pitchFamily="34" charset="0"/>
+                <a:ea typeface="Malgun Gothic" pitchFamily="34" charset="-122"/>
+                <a:cs typeface="Malgun Gothic" pitchFamily="34" charset="-120"/>
+              </a:rPr>
+              <a:t>182→0</a:t>
+            </a:r>
+            <a:endParaRPr lang="en-US" sz="4600" dirty="0"/>
+          </a:p>
+        </p:txBody>
+      </p:sp>
+      <p:sp>
+        <p:nvSpPr>
+          <p:cNvPr id="29" name="Text 27"/>
+          <p:cNvSpPr/>
+          <p:nvPr/>
+        </p:nvSpPr>
+        <p:spPr>
+          <a:xfrm>
+            <a:off x="6931152" y="2651760"/>
+            <a:ext cx="5001768" cy="329184"/>
+          </a:xfrm>
+          <a:prstGeom prst="rect">
+            <a:avLst/>
+          </a:prstGeom>
+          <a:noFill/>
+          <a:ln/>
+        </p:spPr>
+        <p:txBody>
+          <a:bodyPr wrap="square" rtlCol="0" anchor="ctr"/>
+          <a:lstStyle/>
+          <a:p>
+            <a:pPr algn="ctr" indent="0" marL="0">
+              <a:buNone/>
+            </a:pPr>
+            <a:r>
+              <a:rPr lang="en-US" sz="1100" dirty="0">
+                <a:solidFill>
+                  <a:srgbClr val="8E8E9A"/>
+                </a:solidFill>
+                <a:latin typeface="Malgun Gothic" pitchFamily="34" charset="0"/>
+                <a:ea typeface="Malgun Gothic" pitchFamily="34" charset="-122"/>
+                <a:cs typeface="Malgun Gothic" pitchFamily="34" charset="-120"/>
+              </a:rPr>
+              <a:t>Knip 정적 분석 / 불필요한 exports 전수 제거</a:t>
+            </a:r>
+            <a:endParaRPr lang="en-US" sz="1100" dirty="0"/>
+          </a:p>
+        </p:txBody>
+      </p:sp>
+      <p:sp>
+        <p:nvSpPr>
+          <p:cNvPr id="30" name="Shape 28"/>
+          <p:cNvSpPr/>
+          <p:nvPr/>
+        </p:nvSpPr>
+        <p:spPr>
+          <a:xfrm>
+            <a:off x="6675120" y="3712464"/>
+            <a:ext cx="5349240" cy="594360"/>
           </a:xfrm>
           <a:prstGeom prst="rect">
             <a:avLst/>
@@ -10166,117 +10170,78 @@
       </p:sp>
       <p:sp>
         <p:nvSpPr>
-          <p:cNvPr id="29" name="Shape 26"/>
-          <p:cNvSpPr/>
-          <p:nvPr/>
-        </p:nvSpPr>
-        <p:spPr>
-          <a:xfrm>
-            <a:off x="6675120" y="2651760"/>
-            <a:ext cx="64008" cy="1426464"/>
-          </a:xfrm>
-          <a:prstGeom prst="rect">
-            <a:avLst/>
-          </a:prstGeom>
-          <a:solidFill>
-            <a:srgbClr val="818CF8"/>
-          </a:solidFill>
-          <a:ln w="12700">
-            <a:solidFill>
-              <a:srgbClr val="818CF8"/>
-            </a:solidFill>
-            <a:prstDash val="solid"/>
-          </a:ln>
-        </p:spPr>
-      </p:sp>
-      <p:sp>
-        <p:nvSpPr>
-          <p:cNvPr id="30" name="Text 27"/>
-          <p:cNvSpPr/>
-          <p:nvPr/>
-        </p:nvSpPr>
-        <p:spPr>
-          <a:xfrm>
-            <a:off x="6931152" y="2743200"/>
-            <a:ext cx="5001768" cy="841248"/>
-          </a:xfrm>
-          <a:prstGeom prst="rect">
-            <a:avLst/>
-          </a:prstGeom>
-          <a:noFill/>
-          <a:ln/>
-        </p:spPr>
-        <p:txBody>
-          <a:bodyPr wrap="square" rtlCol="0" anchor="ctr"/>
-          <a:lstStyle/>
-          <a:p>
-            <a:pPr algn="ctr" indent="0" marL="0">
-              <a:buNone/>
-            </a:pPr>
-            <a:r>
-              <a:rPr lang="en-US" sz="4000" b="1" dirty="0">
-                <a:solidFill>
-                  <a:srgbClr val="818CF8"/>
-                </a:solidFill>
-                <a:latin typeface="Malgun Gothic" pitchFamily="34" charset="0"/>
-                <a:ea typeface="Malgun Gothic" pitchFamily="34" charset="-122"/>
-                <a:cs typeface="Malgun Gothic" pitchFamily="34" charset="-120"/>
-              </a:rPr>
-              <a:t>40%</a:t>
-            </a:r>
-            <a:endParaRPr lang="en-US" sz="4000" dirty="0"/>
-          </a:p>
-        </p:txBody>
-      </p:sp>
-      <p:sp>
-        <p:nvSpPr>
-          <p:cNvPr id="31" name="Text 28"/>
-          <p:cNvSpPr/>
-          <p:nvPr/>
-        </p:nvSpPr>
-        <p:spPr>
-          <a:xfrm>
-            <a:off x="6931152" y="3639312"/>
-            <a:ext cx="5001768" cy="310896"/>
-          </a:xfrm>
-          <a:prstGeom prst="rect">
-            <a:avLst/>
-          </a:prstGeom>
-          <a:noFill/>
-          <a:ln/>
-        </p:spPr>
-        <p:txBody>
-          <a:bodyPr wrap="square" rtlCol="0" anchor="ctr"/>
-          <a:lstStyle/>
-          <a:p>
-            <a:pPr algn="ctr" indent="0" marL="0">
-              <a:buNone/>
-            </a:pPr>
-            <a:r>
-              <a:rPr lang="en-US" sz="1050" dirty="0">
-                <a:solidFill>
-                  <a:srgbClr val="8E8E9A"/>
-                </a:solidFill>
-                <a:latin typeface="Malgun Gothic" pitchFamily="34" charset="0"/>
-                <a:ea typeface="Malgun Gothic" pitchFamily="34" charset="-122"/>
-                <a:cs typeface="Malgun Gothic" pitchFamily="34" charset="-120"/>
-              </a:rPr>
-              <a:t>유지보수 공수 절감</a:t>
-            </a:r>
-            <a:endParaRPr lang="en-US" sz="1050" dirty="0"/>
-          </a:p>
-        </p:txBody>
-      </p:sp>
-      <p:sp>
-        <p:nvSpPr>
-          <p:cNvPr id="32" name="Shape 29"/>
-          <p:cNvSpPr/>
-          <p:nvPr/>
-        </p:nvSpPr>
-        <p:spPr>
-          <a:xfrm>
-            <a:off x="6675120" y="4187952"/>
-            <a:ext cx="5349240" cy="566928"/>
+          <p:cNvPr id="31" name="Shape 29"/>
+          <p:cNvSpPr/>
+          <p:nvPr/>
+        </p:nvSpPr>
+        <p:spPr>
+          <a:xfrm>
+            <a:off x="6675120" y="3712464"/>
+            <a:ext cx="64008" cy="594360"/>
+          </a:xfrm>
+          <a:prstGeom prst="rect">
+            <a:avLst/>
+          </a:prstGeom>
+          <a:solidFill>
+            <a:srgbClr val="34D399"/>
+          </a:solidFill>
+          <a:ln w="12700">
+            <a:solidFill>
+              <a:srgbClr val="34D399"/>
+            </a:solidFill>
+            <a:prstDash val="solid"/>
+          </a:ln>
+        </p:spPr>
+      </p:sp>
+      <p:sp>
+        <p:nvSpPr>
+          <p:cNvPr id="32" name="Text 30"/>
+          <p:cNvSpPr/>
+          <p:nvPr/>
+        </p:nvSpPr>
+        <p:spPr>
+          <a:xfrm>
+            <a:off x="6931152" y="3776472"/>
+            <a:ext cx="5001768" cy="475488"/>
+          </a:xfrm>
+          <a:prstGeom prst="rect">
+            <a:avLst/>
+          </a:prstGeom>
+          <a:noFill/>
+          <a:ln/>
+        </p:spPr>
+        <p:txBody>
+          <a:bodyPr wrap="square" rtlCol="0" anchor="ctr"/>
+          <a:lstStyle/>
+          <a:p>
+            <a:pPr indent="0" marL="0">
+              <a:buNone/>
+            </a:pPr>
+            <a:r>
+              <a:rPr lang="en-US" sz="1100" dirty="0">
+                <a:solidFill>
+                  <a:srgbClr val="F4F4F6"/>
+                </a:solidFill>
+                <a:latin typeface="Malgun Gothic" pitchFamily="34" charset="0"/>
+                <a:ea typeface="Malgun Gothic" pitchFamily="34" charset="-122"/>
+                <a:cs typeface="Malgun Gothic" pitchFamily="34" charset="-120"/>
+              </a:rPr>
+              <a:t>고객 문의 감소 및 업로드 UX 개선</a:t>
+            </a:r>
+            <a:endParaRPr lang="en-US" sz="1100" dirty="0"/>
+          </a:p>
+        </p:txBody>
+      </p:sp>
+      <p:sp>
+        <p:nvSpPr>
+          <p:cNvPr id="33" name="Shape 31"/>
+          <p:cNvSpPr/>
+          <p:nvPr/>
+        </p:nvSpPr>
+        <p:spPr>
+          <a:xfrm>
+            <a:off x="6675120" y="4425696"/>
+            <a:ext cx="5349240" cy="594360"/>
           </a:xfrm>
           <a:prstGeom prst="rect">
             <a:avLst/>
@@ -10294,14 +10259,14 @@
       </p:sp>
       <p:sp>
         <p:nvSpPr>
-          <p:cNvPr id="33" name="Shape 30"/>
-          <p:cNvSpPr/>
-          <p:nvPr/>
-        </p:nvSpPr>
-        <p:spPr>
-          <a:xfrm>
-            <a:off x="6675120" y="4187952"/>
-            <a:ext cx="64008" cy="566928"/>
+          <p:cNvPr id="34" name="Shape 32"/>
+          <p:cNvSpPr/>
+          <p:nvPr/>
+        </p:nvSpPr>
+        <p:spPr>
+          <a:xfrm>
+            <a:off x="6675120" y="4425696"/>
+            <a:ext cx="64008" cy="594360"/>
           </a:xfrm>
           <a:prstGeom prst="rect">
             <a:avLst/>
@@ -10319,30 +10284,30 @@
       </p:sp>
       <p:sp>
         <p:nvSpPr>
-          <p:cNvPr id="34" name="Text 31"/>
-          <p:cNvSpPr/>
-          <p:nvPr/>
-        </p:nvSpPr>
-        <p:spPr>
-          <a:xfrm>
-            <a:off x="6931152" y="4242816"/>
-            <a:ext cx="5001768" cy="457200"/>
-          </a:xfrm>
-          <a:prstGeom prst="rect">
-            <a:avLst/>
-          </a:prstGeom>
-          <a:noFill/>
-          <a:ln/>
-        </p:spPr>
-        <p:txBody>
-          <a:bodyPr wrap="square" rtlCol="0" anchor="ctr"/>
-          <a:lstStyle/>
-          <a:p>
-            <a:pPr indent="0" marL="0">
-              <a:buNone/>
-            </a:pPr>
-            <a:r>
-              <a:rPr lang="en-US" sz="1050" dirty="0">
+          <p:cNvPr id="35" name="Text 33"/>
+          <p:cNvSpPr/>
+          <p:nvPr/>
+        </p:nvSpPr>
+        <p:spPr>
+          <a:xfrm>
+            <a:off x="6931152" y="4489704"/>
+            <a:ext cx="5001768" cy="475488"/>
+          </a:xfrm>
+          <a:prstGeom prst="rect">
+            <a:avLst/>
+          </a:prstGeom>
+          <a:noFill/>
+          <a:ln/>
+        </p:spPr>
+        <p:txBody>
+          <a:bodyPr wrap="square" rtlCol="0" anchor="ctr"/>
+          <a:lstStyle/>
+          <a:p>
+            <a:pPr indent="0" marL="0">
+              <a:buNone/>
+            </a:pPr>
+            <a:r>
+              <a:rPr lang="en-US" sz="1100" dirty="0">
                 <a:solidFill>
                   <a:srgbClr val="F4F4F6"/>
                 </a:solidFill>
@@ -10350,104 +10315,15 @@
                 <a:ea typeface="Malgun Gothic" pitchFamily="34" charset="-122"/>
                 <a:cs typeface="Malgun Gothic" pitchFamily="34" charset="-120"/>
               </a:rPr>
-              <a:t>고객 문의 감소 및 업로드 UX 개선</a:t>
-            </a:r>
-            <a:endParaRPr lang="en-US" sz="1050" dirty="0"/>
-          </a:p>
-        </p:txBody>
-      </p:sp>
-      <p:sp>
-        <p:nvSpPr>
-          <p:cNvPr id="35" name="Shape 32"/>
-          <p:cNvSpPr/>
-          <p:nvPr/>
-        </p:nvSpPr>
-        <p:spPr>
-          <a:xfrm>
-            <a:off x="6675120" y="4864608"/>
-            <a:ext cx="5349240" cy="566928"/>
-          </a:xfrm>
-          <a:prstGeom prst="rect">
-            <a:avLst/>
-          </a:prstGeom>
-          <a:solidFill>
-            <a:srgbClr val="111116"/>
-          </a:solidFill>
-          <a:ln w="12700">
-            <a:solidFill>
-              <a:srgbClr val="111116"/>
-            </a:solidFill>
-            <a:prstDash val="solid"/>
-          </a:ln>
-        </p:spPr>
-      </p:sp>
-      <p:sp>
-        <p:nvSpPr>
-          <p:cNvPr id="36" name="Shape 33"/>
-          <p:cNvSpPr/>
-          <p:nvPr/>
-        </p:nvSpPr>
-        <p:spPr>
-          <a:xfrm>
-            <a:off x="6675120" y="4864608"/>
-            <a:ext cx="64008" cy="566928"/>
-          </a:xfrm>
-          <a:prstGeom prst="rect">
-            <a:avLst/>
-          </a:prstGeom>
-          <a:solidFill>
-            <a:srgbClr val="34D399"/>
-          </a:solidFill>
-          <a:ln w="12700">
-            <a:solidFill>
-              <a:srgbClr val="34D399"/>
-            </a:solidFill>
-            <a:prstDash val="solid"/>
-          </a:ln>
-        </p:spPr>
-      </p:sp>
-      <p:sp>
-        <p:nvSpPr>
-          <p:cNvPr id="37" name="Text 34"/>
-          <p:cNvSpPr/>
-          <p:nvPr/>
-        </p:nvSpPr>
-        <p:spPr>
-          <a:xfrm>
-            <a:off x="6931152" y="4919472"/>
-            <a:ext cx="5001768" cy="457200"/>
-          </a:xfrm>
-          <a:prstGeom prst="rect">
-            <a:avLst/>
-          </a:prstGeom>
-          <a:noFill/>
-          <a:ln/>
-        </p:spPr>
-        <p:txBody>
-          <a:bodyPr wrap="square" rtlCol="0" anchor="ctr"/>
-          <a:lstStyle/>
-          <a:p>
-            <a:pPr indent="0" marL="0">
-              <a:buNone/>
-            </a:pPr>
-            <a:r>
-              <a:rPr lang="en-US" sz="1050" dirty="0">
-                <a:solidFill>
-                  <a:srgbClr val="F4F4F6"/>
-                </a:solidFill>
-                <a:latin typeface="Malgun Gothic" pitchFamily="34" charset="0"/>
-                <a:ea typeface="Malgun Gothic" pitchFamily="34" charset="-122"/>
-                <a:cs typeface="Malgun Gothic" pitchFamily="34" charset="-120"/>
-              </a:rPr>
               <a:t>팀원 온보딩·협업 효율성 강화</a:t>
             </a:r>
-            <a:endParaRPr lang="en-US" sz="1050" dirty="0"/>
-          </a:p>
-        </p:txBody>
-      </p:sp>
-      <p:sp>
-        <p:nvSpPr>
-          <p:cNvPr id="38" name="Shape 35"/>
+            <a:endParaRPr lang="en-US" sz="1100" dirty="0"/>
+          </a:p>
+        </p:txBody>
+      </p:sp>
+      <p:sp>
+        <p:nvSpPr>
+          <p:cNvPr id="36" name="Shape 34"/>
           <p:cNvSpPr/>
           <p:nvPr/>
         </p:nvSpPr>
@@ -10472,7 +10348,7 @@
       </p:sp>
       <p:sp>
         <p:nvSpPr>
-          <p:cNvPr id="39" name="Text 36"/>
+          <p:cNvPr id="37" name="Text 35"/>
           <p:cNvSpPr/>
           <p:nvPr/>
         </p:nvSpPr>
@@ -11166,63 +11042,144 @@
           </a:p>
         </p:txBody>
       </p:sp>
-      <p:pic>
-        <p:nvPicPr>
-          <p:cNvPr id="21" name="Image 0" descr="/Users/jinwon/Desktop/jinwon-portfolio/apps/web/public/images/projects/customer-1.png">    </p:cNvPr>
-          <p:cNvPicPr>
-            <a:picLocks noChangeAspect="1"/>
-          </p:cNvPicPr>
-          <p:nvPr/>
-        </p:nvPicPr>
-        <p:blipFill>
-          <a:blip r:embed="rId1"/>
-          <a:srcRect l="0" r="0" t="0" b="0"/>
-          <a:stretch/>
-        </p:blipFill>
+      <p:sp>
+        <p:nvSpPr>
+          <p:cNvPr id="21" name="Shape 19"/>
+          <p:cNvSpPr/>
+          <p:nvPr/>
+        </p:nvSpPr>
         <p:spPr>
           <a:xfrm>
             <a:off x="6675120" y="1298448"/>
-            <a:ext cx="5349240" cy="1261872"/>
-          </a:xfrm>
-          <a:prstGeom prst="rect">
-            <a:avLst/>
-          </a:prstGeom>
-        </p:spPr>
-      </p:pic>
-      <p:sp>
-        <p:nvSpPr>
-          <p:cNvPr id="22" name="Shape 19"/>
+            <a:ext cx="5349240" cy="2231136"/>
+          </a:xfrm>
+          <a:prstGeom prst="rect">
+            <a:avLst/>
+          </a:prstGeom>
+          <a:solidFill>
+            <a:srgbClr val="111116"/>
+          </a:solidFill>
+          <a:ln w="12700">
+            <a:solidFill>
+              <a:srgbClr val="111116"/>
+            </a:solidFill>
+            <a:prstDash val="solid"/>
+          </a:ln>
+        </p:spPr>
+      </p:sp>
+      <p:sp>
+        <p:nvSpPr>
+          <p:cNvPr id="22" name="Shape 20"/>
           <p:cNvSpPr/>
           <p:nvPr/>
         </p:nvSpPr>
         <p:spPr>
           <a:xfrm>
             <a:off x="6675120" y="1298448"/>
-            <a:ext cx="5349240" cy="1261872"/>
-          </a:xfrm>
-          <a:prstGeom prst="rect">
-            <a:avLst/>
-          </a:prstGeom>
-          <a:ln w="12700">
-            <a:solidFill>
-              <a:srgbClr val="818CF8">
-                <a:alpha val="50000"/>
-              </a:srgbClr>
-            </a:solidFill>
-            <a:prstDash val="solid"/>
-          </a:ln>
-        </p:spPr>
-      </p:sp>
-      <p:sp>
-        <p:nvSpPr>
-          <p:cNvPr id="23" name="Shape 20"/>
-          <p:cNvSpPr/>
-          <p:nvPr/>
-        </p:nvSpPr>
-        <p:spPr>
-          <a:xfrm>
-            <a:off x="6675120" y="2651760"/>
-            <a:ext cx="5349240" cy="1426464"/>
+            <a:ext cx="64008" cy="2231136"/>
+          </a:xfrm>
+          <a:prstGeom prst="rect">
+            <a:avLst/>
+          </a:prstGeom>
+          <a:solidFill>
+            <a:srgbClr val="818CF8"/>
+          </a:solidFill>
+          <a:ln w="12700">
+            <a:solidFill>
+              <a:srgbClr val="818CF8"/>
+            </a:solidFill>
+            <a:prstDash val="solid"/>
+          </a:ln>
+        </p:spPr>
+      </p:sp>
+      <p:sp>
+        <p:nvSpPr>
+          <p:cNvPr id="23" name="Text 21"/>
+          <p:cNvSpPr/>
+          <p:nvPr/>
+        </p:nvSpPr>
+        <p:spPr>
+          <a:xfrm>
+            <a:off x="6931152" y="1463040"/>
+            <a:ext cx="5001768" cy="1188720"/>
+          </a:xfrm>
+          <a:prstGeom prst="rect">
+            <a:avLst/>
+          </a:prstGeom>
+          <a:noFill/>
+          <a:ln/>
+        </p:spPr>
+        <p:txBody>
+          <a:bodyPr wrap="square" rtlCol="0" anchor="ctr"/>
+          <a:lstStyle/>
+          <a:p>
+            <a:pPr algn="ctr" indent="0" marL="0">
+              <a:buNone/>
+            </a:pPr>
+            <a:r>
+              <a:rPr lang="en-US" sz="4600" b="1" dirty="0">
+                <a:solidFill>
+                  <a:srgbClr val="818CF8"/>
+                </a:solidFill>
+                <a:latin typeface="Malgun Gothic" pitchFamily="34" charset="0"/>
+                <a:ea typeface="Malgun Gothic" pitchFamily="34" charset="-122"/>
+                <a:cs typeface="Malgun Gothic" pitchFamily="34" charset="-120"/>
+              </a:rPr>
+              <a:t>FE 2인</a:t>
+            </a:r>
+            <a:endParaRPr lang="en-US" sz="4600" dirty="0"/>
+          </a:p>
+        </p:txBody>
+      </p:sp>
+      <p:sp>
+        <p:nvSpPr>
+          <p:cNvPr id="24" name="Text 22"/>
+          <p:cNvSpPr/>
+          <p:nvPr/>
+        </p:nvSpPr>
+        <p:spPr>
+          <a:xfrm>
+            <a:off x="6931152" y="2651760"/>
+            <a:ext cx="5001768" cy="329184"/>
+          </a:xfrm>
+          <a:prstGeom prst="rect">
+            <a:avLst/>
+          </a:prstGeom>
+          <a:noFill/>
+          <a:ln/>
+        </p:spPr>
+        <p:txBody>
+          <a:bodyPr wrap="square" rtlCol="0" anchor="ctr"/>
+          <a:lstStyle/>
+          <a:p>
+            <a:pPr algn="ctr" indent="0" marL="0">
+              <a:buNone/>
+            </a:pPr>
+            <a:r>
+              <a:rPr lang="en-US" sz="1100" dirty="0">
+                <a:solidFill>
+                  <a:srgbClr val="8E8E9A"/>
+                </a:solidFill>
+                <a:latin typeface="Malgun Gothic" pitchFamily="34" charset="0"/>
+                <a:ea typeface="Malgun Gothic" pitchFamily="34" charset="-122"/>
+                <a:cs typeface="Malgun Gothic" pitchFamily="34" charset="-120"/>
+              </a:rPr>
+              <a:t>설계 → 배포 전 과정 주도</a:t>
+            </a:r>
+            <a:endParaRPr lang="en-US" sz="1100" dirty="0"/>
+          </a:p>
+        </p:txBody>
+      </p:sp>
+      <p:sp>
+        <p:nvSpPr>
+          <p:cNvPr id="25" name="Shape 23"/>
+          <p:cNvSpPr/>
+          <p:nvPr/>
+        </p:nvSpPr>
+        <p:spPr>
+          <a:xfrm>
+            <a:off x="6675120" y="3712464"/>
+            <a:ext cx="5349240" cy="594360"/>
           </a:xfrm>
           <a:prstGeom prst="rect">
             <a:avLst/>
@@ -11240,117 +11197,78 @@
       </p:sp>
       <p:sp>
         <p:nvSpPr>
-          <p:cNvPr id="24" name="Shape 21"/>
-          <p:cNvSpPr/>
-          <p:nvPr/>
-        </p:nvSpPr>
-        <p:spPr>
-          <a:xfrm>
-            <a:off x="6675120" y="2651760"/>
-            <a:ext cx="64008" cy="1426464"/>
-          </a:xfrm>
-          <a:prstGeom prst="rect">
-            <a:avLst/>
-          </a:prstGeom>
-          <a:solidFill>
-            <a:srgbClr val="818CF8"/>
-          </a:solidFill>
-          <a:ln w="12700">
-            <a:solidFill>
-              <a:srgbClr val="818CF8"/>
-            </a:solidFill>
-            <a:prstDash val="solid"/>
-          </a:ln>
-        </p:spPr>
-      </p:sp>
-      <p:sp>
-        <p:nvSpPr>
-          <p:cNvPr id="25" name="Text 22"/>
-          <p:cNvSpPr/>
-          <p:nvPr/>
-        </p:nvSpPr>
-        <p:spPr>
-          <a:xfrm>
-            <a:off x="6931152" y="2743200"/>
-            <a:ext cx="5001768" cy="841248"/>
-          </a:xfrm>
-          <a:prstGeom prst="rect">
-            <a:avLst/>
-          </a:prstGeom>
-          <a:noFill/>
-          <a:ln/>
-        </p:spPr>
-        <p:txBody>
-          <a:bodyPr wrap="square" rtlCol="0" anchor="ctr"/>
-          <a:lstStyle/>
-          <a:p>
-            <a:pPr algn="ctr" indent="0" marL="0">
-              <a:buNone/>
-            </a:pPr>
-            <a:r>
-              <a:rPr lang="en-US" sz="4000" b="1" dirty="0">
-                <a:solidFill>
-                  <a:srgbClr val="818CF8"/>
-                </a:solidFill>
-                <a:latin typeface="Malgun Gothic" pitchFamily="34" charset="0"/>
-                <a:ea typeface="Malgun Gothic" pitchFamily="34" charset="-122"/>
-                <a:cs typeface="Malgun Gothic" pitchFamily="34" charset="-120"/>
-              </a:rPr>
-              <a:t>FE 2인</a:t>
-            </a:r>
-            <a:endParaRPr lang="en-US" sz="4000" dirty="0"/>
-          </a:p>
-        </p:txBody>
-      </p:sp>
-      <p:sp>
-        <p:nvSpPr>
-          <p:cNvPr id="26" name="Text 23"/>
-          <p:cNvSpPr/>
-          <p:nvPr/>
-        </p:nvSpPr>
-        <p:spPr>
-          <a:xfrm>
-            <a:off x="6931152" y="3639312"/>
-            <a:ext cx="5001768" cy="310896"/>
-          </a:xfrm>
-          <a:prstGeom prst="rect">
-            <a:avLst/>
-          </a:prstGeom>
-          <a:noFill/>
-          <a:ln/>
-        </p:spPr>
-        <p:txBody>
-          <a:bodyPr wrap="square" rtlCol="0" anchor="ctr"/>
-          <a:lstStyle/>
-          <a:p>
-            <a:pPr algn="ctr" indent="0" marL="0">
-              <a:buNone/>
-            </a:pPr>
-            <a:r>
-              <a:rPr lang="en-US" sz="1050" dirty="0">
-                <a:solidFill>
-                  <a:srgbClr val="8E8E9A"/>
-                </a:solidFill>
-                <a:latin typeface="Malgun Gothic" pitchFamily="34" charset="0"/>
-                <a:ea typeface="Malgun Gothic" pitchFamily="34" charset="-122"/>
-                <a:cs typeface="Malgun Gothic" pitchFamily="34" charset="-120"/>
-              </a:rPr>
-              <a:t>설계 → 배포 전 과정 주도</a:t>
-            </a:r>
-            <a:endParaRPr lang="en-US" sz="1050" dirty="0"/>
-          </a:p>
-        </p:txBody>
-      </p:sp>
-      <p:sp>
-        <p:nvSpPr>
-          <p:cNvPr id="27" name="Shape 24"/>
-          <p:cNvSpPr/>
-          <p:nvPr/>
-        </p:nvSpPr>
-        <p:spPr>
-          <a:xfrm>
-            <a:off x="6675120" y="4187952"/>
-            <a:ext cx="5349240" cy="566928"/>
+          <p:cNvPr id="26" name="Shape 24"/>
+          <p:cNvSpPr/>
+          <p:nvPr/>
+        </p:nvSpPr>
+        <p:spPr>
+          <a:xfrm>
+            <a:off x="6675120" y="3712464"/>
+            <a:ext cx="64008" cy="594360"/>
+          </a:xfrm>
+          <a:prstGeom prst="rect">
+            <a:avLst/>
+          </a:prstGeom>
+          <a:solidFill>
+            <a:srgbClr val="34D399"/>
+          </a:solidFill>
+          <a:ln w="12700">
+            <a:solidFill>
+              <a:srgbClr val="34D399"/>
+            </a:solidFill>
+            <a:prstDash val="solid"/>
+          </a:ln>
+        </p:spPr>
+      </p:sp>
+      <p:sp>
+        <p:nvSpPr>
+          <p:cNvPr id="27" name="Text 25"/>
+          <p:cNvSpPr/>
+          <p:nvPr/>
+        </p:nvSpPr>
+        <p:spPr>
+          <a:xfrm>
+            <a:off x="6931152" y="3776472"/>
+            <a:ext cx="5001768" cy="475488"/>
+          </a:xfrm>
+          <a:prstGeom prst="rect">
+            <a:avLst/>
+          </a:prstGeom>
+          <a:noFill/>
+          <a:ln/>
+        </p:spPr>
+        <p:txBody>
+          <a:bodyPr wrap="square" rtlCol="0" anchor="ctr"/>
+          <a:lstStyle/>
+          <a:p>
+            <a:pPr indent="0" marL="0">
+              <a:buNone/>
+            </a:pPr>
+            <a:r>
+              <a:rPr lang="en-US" sz="1100" dirty="0">
+                <a:solidFill>
+                  <a:srgbClr val="F4F4F6"/>
+                </a:solidFill>
+                <a:latin typeface="Malgun Gothic" pitchFamily="34" charset="0"/>
+                <a:ea typeface="Malgun Gothic" pitchFamily="34" charset="-122"/>
+                <a:cs typeface="Malgun Gothic" pitchFamily="34" charset="-120"/>
+              </a:rPr>
+              <a:t>대규모 관리 시스템 0→1 구축 전 과정 경험</a:t>
+            </a:r>
+            <a:endParaRPr lang="en-US" sz="1100" dirty="0"/>
+          </a:p>
+        </p:txBody>
+      </p:sp>
+      <p:sp>
+        <p:nvSpPr>
+          <p:cNvPr id="28" name="Shape 26"/>
+          <p:cNvSpPr/>
+          <p:nvPr/>
+        </p:nvSpPr>
+        <p:spPr>
+          <a:xfrm>
+            <a:off x="6675120" y="4425696"/>
+            <a:ext cx="5349240" cy="594360"/>
           </a:xfrm>
           <a:prstGeom prst="rect">
             <a:avLst/>
@@ -11368,14 +11286,14 @@
       </p:sp>
       <p:sp>
         <p:nvSpPr>
-          <p:cNvPr id="28" name="Shape 25"/>
-          <p:cNvSpPr/>
-          <p:nvPr/>
-        </p:nvSpPr>
-        <p:spPr>
-          <a:xfrm>
-            <a:off x="6675120" y="4187952"/>
-            <a:ext cx="64008" cy="566928"/>
+          <p:cNvPr id="29" name="Shape 27"/>
+          <p:cNvSpPr/>
+          <p:nvPr/>
+        </p:nvSpPr>
+        <p:spPr>
+          <a:xfrm>
+            <a:off x="6675120" y="4425696"/>
+            <a:ext cx="64008" cy="594360"/>
           </a:xfrm>
           <a:prstGeom prst="rect">
             <a:avLst/>
@@ -11393,30 +11311,30 @@
       </p:sp>
       <p:sp>
         <p:nvSpPr>
-          <p:cNvPr id="29" name="Text 26"/>
-          <p:cNvSpPr/>
-          <p:nvPr/>
-        </p:nvSpPr>
-        <p:spPr>
-          <a:xfrm>
-            <a:off x="6931152" y="4242816"/>
-            <a:ext cx="5001768" cy="457200"/>
-          </a:xfrm>
-          <a:prstGeom prst="rect">
-            <a:avLst/>
-          </a:prstGeom>
-          <a:noFill/>
-          <a:ln/>
-        </p:spPr>
-        <p:txBody>
-          <a:bodyPr wrap="square" rtlCol="0" anchor="ctr"/>
-          <a:lstStyle/>
-          <a:p>
-            <a:pPr indent="0" marL="0">
-              <a:buNone/>
-            </a:pPr>
-            <a:r>
-              <a:rPr lang="en-US" sz="1050" dirty="0">
+          <p:cNvPr id="30" name="Text 28"/>
+          <p:cNvSpPr/>
+          <p:nvPr/>
+        </p:nvSpPr>
+        <p:spPr>
+          <a:xfrm>
+            <a:off x="6931152" y="4489704"/>
+            <a:ext cx="5001768" cy="475488"/>
+          </a:xfrm>
+          <a:prstGeom prst="rect">
+            <a:avLst/>
+          </a:prstGeom>
+          <a:noFill/>
+          <a:ln/>
+        </p:spPr>
+        <p:txBody>
+          <a:bodyPr wrap="square" rtlCol="0" anchor="ctr"/>
+          <a:lstStyle/>
+          <a:p>
+            <a:pPr indent="0" marL="0">
+              <a:buNone/>
+            </a:pPr>
+            <a:r>
+              <a:rPr lang="en-US" sz="1100" dirty="0">
                 <a:solidFill>
                   <a:srgbClr val="F4F4F6"/>
                 </a:solidFill>
@@ -11424,104 +11342,15 @@
                 <a:ea typeface="Malgun Gothic" pitchFamily="34" charset="-122"/>
                 <a:cs typeface="Malgun Gothic" pitchFamily="34" charset="-120"/>
               </a:rPr>
-              <a:t>대규모 관리 시스템 0→1 구축 전 과정 경험</a:t>
-            </a:r>
-            <a:endParaRPr lang="en-US" sz="1050" dirty="0"/>
-          </a:p>
-        </p:txBody>
-      </p:sp>
-      <p:sp>
-        <p:nvSpPr>
-          <p:cNvPr id="30" name="Shape 27"/>
-          <p:cNvSpPr/>
-          <p:nvPr/>
-        </p:nvSpPr>
-        <p:spPr>
-          <a:xfrm>
-            <a:off x="6675120" y="4864608"/>
-            <a:ext cx="5349240" cy="566928"/>
-          </a:xfrm>
-          <a:prstGeom prst="rect">
-            <a:avLst/>
-          </a:prstGeom>
-          <a:solidFill>
-            <a:srgbClr val="111116"/>
-          </a:solidFill>
-          <a:ln w="12700">
-            <a:solidFill>
-              <a:srgbClr val="111116"/>
-            </a:solidFill>
-            <a:prstDash val="solid"/>
-          </a:ln>
-        </p:spPr>
-      </p:sp>
-      <p:sp>
-        <p:nvSpPr>
-          <p:cNvPr id="31" name="Shape 28"/>
-          <p:cNvSpPr/>
-          <p:nvPr/>
-        </p:nvSpPr>
-        <p:spPr>
-          <a:xfrm>
-            <a:off x="6675120" y="4864608"/>
-            <a:ext cx="64008" cy="566928"/>
-          </a:xfrm>
-          <a:prstGeom prst="rect">
-            <a:avLst/>
-          </a:prstGeom>
-          <a:solidFill>
-            <a:srgbClr val="34D399"/>
-          </a:solidFill>
-          <a:ln w="12700">
-            <a:solidFill>
-              <a:srgbClr val="34D399"/>
-            </a:solidFill>
-            <a:prstDash val="solid"/>
-          </a:ln>
-        </p:spPr>
-      </p:sp>
-      <p:sp>
-        <p:nvSpPr>
-          <p:cNvPr id="32" name="Text 29"/>
-          <p:cNvSpPr/>
-          <p:nvPr/>
-        </p:nvSpPr>
-        <p:spPr>
-          <a:xfrm>
-            <a:off x="6931152" y="4919472"/>
-            <a:ext cx="5001768" cy="457200"/>
-          </a:xfrm>
-          <a:prstGeom prst="rect">
-            <a:avLst/>
-          </a:prstGeom>
-          <a:noFill/>
-          <a:ln/>
-        </p:spPr>
-        <p:txBody>
-          <a:bodyPr wrap="square" rtlCol="0" anchor="ctr"/>
-          <a:lstStyle/>
-          <a:p>
-            <a:pPr indent="0" marL="0">
-              <a:buNone/>
-            </a:pPr>
-            <a:r>
-              <a:rPr lang="en-US" sz="1050" dirty="0">
-                <a:solidFill>
-                  <a:srgbClr val="F4F4F6"/>
-                </a:solidFill>
-                <a:latin typeface="Malgun Gothic" pitchFamily="34" charset="0"/>
-                <a:ea typeface="Malgun Gothic" pitchFamily="34" charset="-122"/>
-                <a:cs typeface="Malgun Gothic" pitchFamily="34" charset="-120"/>
-              </a:rPr>
               <a:t>운영자 피드백 기반 직관적 환경 완성</a:t>
             </a:r>
-            <a:endParaRPr lang="en-US" sz="1050" dirty="0"/>
-          </a:p>
-        </p:txBody>
-      </p:sp>
-      <p:sp>
-        <p:nvSpPr>
-          <p:cNvPr id="33" name="Shape 30"/>
+            <a:endParaRPr lang="en-US" sz="1100" dirty="0"/>
+          </a:p>
+        </p:txBody>
+      </p:sp>
+      <p:sp>
+        <p:nvSpPr>
+          <p:cNvPr id="31" name="Shape 29"/>
           <p:cNvSpPr/>
           <p:nvPr/>
         </p:nvSpPr>
@@ -11546,7 +11375,7 @@
       </p:sp>
       <p:sp>
         <p:nvSpPr>
-          <p:cNvPr id="34" name="Text 31"/>
+          <p:cNvPr id="32" name="Text 30"/>
           <p:cNvSpPr/>
           <p:nvPr/>
         </p:nvSpPr>
@@ -12315,7 +12144,7 @@
               <a:buNone/>
             </a:pPr>
             <a:r>
-              <a:rPr lang="en-US" sz="5200" b="1" dirty="0">
+              <a:rPr lang="en-US" sz="4600" b="1" dirty="0">
                 <a:solidFill>
                   <a:srgbClr val="818CF8"/>
                 </a:solidFill>
@@ -12325,7 +12154,7 @@
               </a:rPr>
               <a:t>30→1</a:t>
             </a:r>
-            <a:endParaRPr lang="en-US" sz="5200" dirty="0"/>
+            <a:endParaRPr lang="en-US" sz="4600" dirty="0"/>
           </a:p>
         </p:txBody>
       </p:sp>
@@ -13303,7 +13132,7 @@
               <a:buNone/>
             </a:pPr>
             <a:r>
-              <a:rPr lang="en-US" sz="5200" b="1" dirty="0">
+              <a:rPr lang="en-US" sz="4600" b="1" dirty="0">
                 <a:solidFill>
                   <a:srgbClr val="818CF8"/>
                 </a:solidFill>
@@ -13313,7 +13142,7 @@
               </a:rPr>
               <a:t>통합</a:t>
             </a:r>
-            <a:endParaRPr lang="en-US" sz="5200" dirty="0"/>
+            <a:endParaRPr lang="en-US" sz="4600" dirty="0"/>
           </a:p>
         </p:txBody>
       </p:sp>

</xml_diff>